<commit_message>
rebuild the final report in the vit bcse497j template with per-student copies and apa references, add ai annotator labels and licence notes
</commit_message>
<xml_diff>
--- a/report/MedBridge_Review_Presentation.pptx
+++ b/report/MedBridge_Review_Presentation.pptx
@@ -632,7 +632,7 @@
           <a:p/>
           <a:p>
             <a:r>
-              <a:t>Sources: evaluation/datasets/hallubench_v1.json; evaluation/results/summary.json; medbridge/core/pipeline_types.py; report/figures/evaluation_design.png.</a:t>
+              <a:t>Sources: evaluation/datasets/hallubench_v1.json; evaluation/results/summary.json; evaluation/results/ai_annotation_agreement.json; medbridge/core/pipeline_types.py; report/figures/evaluation_design.png.</a:t>
             </a:r>
           </a:p>
         </p:txBody>
@@ -1716,7 +1716,7 @@
           </a:p>
           <a:p>
             <a:r>
-              <a:t>2. How was hallucination measured? Atomic claims judged by an LLM judge from another model family on all 10 conditions; an NLI judge re-labelled the claims of the ungated conditions for agreement (response-level kappa 0.683 [0.613, 0.753]); a 50-item human sheet is exported and still to be labelled.</a:t>
+              <a:t>2. How was hallucination measured? Atomic claims judged by an LLM judge from another model family on all 10 conditions; an NLI judge re-labelled the claims of the ungated conditions for agreement (response-level kappa 0.683 [0.613, 0.753]); no human labels were collected, but an AI annotator (not a human) labelled 872 claims of a 50-item sample and agreed with the LLM judge at κ 0.50, while finding answered C5 and C1 responses about equally often unsupported.</a:t>
             </a:r>
           </a:p>
           <a:p>
@@ -1752,7 +1752,7 @@
           <a:p/>
           <a:p>
             <a:r>
-              <a:t>Sources: evaluation/results/summary.json; reports/adversarial_live_report.json.</a:t>
+              <a:t>Sources: evaluation/results/summary.json; evaluation/results/ai_annotation_agreement.json; reports/adversarial_live_report.json.</a:t>
             </a:r>
           </a:p>
         </p:txBody>
@@ -9911,7 +9911,7 @@
                 </a:solidFill>
                 <a:latin typeface="Arial"/>
               </a:rPr>
-              <a:t>Cohen's κ 0.683 [0.613, 0.753] on 790 paired responses; 50-item human sheet exported, labels pending</a:t>
+              <a:t>Cohen's κ 0.683 [0.613, 0.753] on 790 paired responses; AI annotator (not human) vs LLM judge κ 0.50</a:t>
             </a:r>
           </a:p>
         </p:txBody>
@@ -9944,13 +9944,13 @@
               </a:lnSpc>
             </a:pPr>
             <a:r>
-              <a:rPr sz="1000" b="0" i="0">
+              <a:rPr sz="900" b="0" i="0">
                 <a:solidFill>
                   <a:srgbClr val="8A94A6"/>
                 </a:solidFill>
                 <a:latin typeface="Arial"/>
               </a:rPr>
-              <a:t>Sources: evaluation/datasets/hallubench_v1.json · evaluation/results/summary.json · medbridge/core/pipeline_types.py · report/figures/evaluation_design.png</a:t>
+              <a:t>Sources: evaluation/datasets/hallubench_v1.json · evaluation/results/summary.json · evaluation/results/ai_annotation_agreement.json · medbridge/core/pipeline_types.py · report/figures/evaluation_design.png</a:t>
             </a:r>
           </a:p>
         </p:txBody>
@@ -27050,7 +27050,7 @@
                 </a:solidFill>
                 <a:latin typeface="Arial"/>
               </a:rPr>
-              <a:t>3,474 passed</a:t>
+              <a:t>3,480 passed</a:t>
             </a:r>
           </a:p>
         </p:txBody>
@@ -28143,7 +28143,7 @@
                           </a:solidFill>
                           <a:latin typeface="Arial"/>
                         </a:rPr>
-                        <a:t>200</a:t>
+                        <a:t>202</a:t>
                       </a:r>
                     </a:p>
                   </a:txBody>
@@ -28518,7 +28518,7 @@
                           </a:solidFill>
                           <a:latin typeface="Arial"/>
                         </a:rPr>
-                        <a:t>71</a:t>
+                        <a:t>75</a:t>
                       </a:r>
                     </a:p>
                   </a:txBody>
@@ -28768,7 +28768,7 @@
                           </a:solidFill>
                           <a:latin typeface="Arial"/>
                         </a:rPr>
-                        <a:t>1636</a:t>
+                        <a:t>1642</a:t>
                       </a:r>
                     </a:p>
                   </a:txBody>
@@ -29417,7 +29417,7 @@
                 </a:solidFill>
                 <a:latin typeface="Arial"/>
               </a:rPr>
-              <a:t> every rate and test uses the LLM judge; the NLI judge stopped early (C0, C1, C1G only) and the 50-item human sheet awaits labels</a:t>
+              <a:t> every rate and test uses the LLM judge; the NLI judge stopped early (C0, C1, C1G only); no human labels, and a stricter AI annotator agreed only moderately</a:t>
             </a:r>
           </a:p>
           <a:p>
@@ -29714,7 +29714,7 @@
                 </a:solidFill>
                 <a:latin typeface="Arial"/>
               </a:rPr>
-              <a:t>Clinician-validated benchmark and the completed human annotation</a:t>
+              <a:t>Clinician-validated benchmark and human annotation</a:t>
             </a:r>
           </a:p>
           <a:p>

</xml_diff>